<commit_message>
Strip speaker notes from the repo copies of both decks
The notes are written to the instructor, not the students - stage directions
about when to pause, what to expect from the room, which traps to let people
find. The OneDrive originals keep them; the public copies do not.

Adds 0_System/scripts/strip-notes.py so the repo copy can be refreshed after
any edit. It drops the notesSlide relationship (checking has_notes_slide first,
since touching .notes_slide creates one), then reopens the output and counts to
confirm rather than assuming. Verified: 0 notesSlide parts and no instructor
phrasing anywhere in the package XML.

Co-Authored-By: Claude Opus 5 <noreply@anthropic.com>
</commit_message>
<xml_diff>
--- a/1_Class/Slides/INFO4610-Session1.pptx
+++ b/1_Class/Slides/INFO4610-Session1.pptx
@@ -472,1266 +472,6 @@
     </a:lvl9pPr>
   </p:notesStyle>
 </p:notesMaster>
-</file>
-
-<file path=ppt/notesSlides/notesSlide1.xml><?xml version="1.0" encoding="utf-8"?>
-<p:notes xmlns:a="http://schemas.openxmlformats.org/drawingml/2006/main" xmlns:p="http://schemas.openxmlformats.org/presentationml/2006/main" xmlns:r="http://schemas.openxmlformats.org/officeDocument/2006/relationships">
-  <p:cSld>
-    <p:spTree>
-      <p:nvGrpSpPr>
-        <p:cNvPr id="1" name=""/>
-        <p:cNvGrpSpPr/>
-        <p:nvPr/>
-      </p:nvGrpSpPr>
-      <p:grpSpPr>
-        <a:xfrm>
-          <a:off x="0" y="0"/>
-          <a:ext cx="0" cy="0"/>
-          <a:chOff x="0" y="0"/>
-          <a:chExt cx="0" cy="0"/>
-        </a:xfrm>
-      </p:grpSpPr>
-      <p:sp>
-        <p:nvSpPr>
-          <p:cNvPr id="2" name="Slide Image Placeholder 1"/>
-          <p:cNvSpPr>
-            <a:spLocks noGrp="1"/>
-          </p:cNvSpPr>
-          <p:nvPr>
-            <p:ph type="sldImg" idx="2"/>
-          </p:nvPr>
-        </p:nvSpPr>
-        <p:spPr/>
-      </p:sp>
-      <p:sp>
-        <p:nvSpPr>
-          <p:cNvPr id="3" name="Notes Placeholder 2"/>
-          <p:cNvSpPr>
-            <a:spLocks noGrp="1"/>
-          </p:cNvSpPr>
-          <p:nvPr>
-            <p:ph type="body" idx="3" sz="quarter"/>
-          </p:nvPr>
-        </p:nvSpPr>
-        <p:spPr/>
-        <p:txBody>
-          <a:bodyPr/>
-          <a:lstStyle/>
-          <a:p>
-            <a:r>
-              <a:t>Welcome. Tonight we do NOT build anything, and that is deliberate. Tonight is about making sure that what you build next week is worth building.</a:t>
-            </a:r>
-          </a:p>
-        </p:txBody>
-      </p:sp>
-      <p:sp>
-        <p:nvSpPr>
-          <p:cNvPr id="4" name="Slide Number Placeholder 3"/>
-          <p:cNvSpPr>
-            <a:spLocks noGrp="1"/>
-          </p:cNvSpPr>
-          <p:nvPr>
-            <p:ph type="sldNum" idx="5" sz="quarter"/>
-          </p:nvPr>
-        </p:nvSpPr>
-        <p:spPr/>
-      </p:sp>
-    </p:spTree>
-  </p:cSld>
-  <p:clrMapOvr>
-    <a:masterClrMapping/>
-  </p:clrMapOvr>
-</p:notes>
-</file>
-
-<file path=ppt/notesSlides/notesSlide10.xml><?xml version="1.0" encoding="utf-8"?>
-<p:notes xmlns:a="http://schemas.openxmlformats.org/drawingml/2006/main" xmlns:p="http://schemas.openxmlformats.org/presentationml/2006/main" xmlns:r="http://schemas.openxmlformats.org/officeDocument/2006/relationships">
-  <p:cSld>
-    <p:spTree>
-      <p:nvGrpSpPr>
-        <p:cNvPr id="1" name=""/>
-        <p:cNvGrpSpPr/>
-        <p:nvPr/>
-      </p:nvGrpSpPr>
-      <p:grpSpPr>
-        <a:xfrm>
-          <a:off x="0" y="0"/>
-          <a:ext cx="0" cy="0"/>
-          <a:chOff x="0" y="0"/>
-          <a:chExt cx="0" cy="0"/>
-        </a:xfrm>
-      </p:grpSpPr>
-      <p:sp>
-        <p:nvSpPr>
-          <p:cNvPr id="2" name="Slide Image Placeholder 1"/>
-          <p:cNvSpPr>
-            <a:spLocks noGrp="1"/>
-          </p:cNvSpPr>
-          <p:nvPr>
-            <p:ph type="sldImg" idx="2"/>
-          </p:nvPr>
-        </p:nvSpPr>
-        <p:spPr/>
-      </p:sp>
-      <p:sp>
-        <p:nvSpPr>
-          <p:cNvPr id="3" name="Notes Placeholder 2"/>
-          <p:cNvSpPr>
-            <a:spLocks noGrp="1"/>
-          </p:cNvSpPr>
-          <p:nvPr>
-            <p:ph type="body" idx="3" sz="quarter"/>
-          </p:nvPr>
-        </p:nvSpPr>
-        <p:spPr/>
-        <p:txBody>
-          <a:bodyPr/>
-          <a:lstStyle/>
-          <a:p>
-            <a:r>
-              <a:t>Number 4 is in crimson because it is the one people cannot answer. Spend real time there.</a:t>
-            </a:r>
-          </a:p>
-        </p:txBody>
-      </p:sp>
-      <p:sp>
-        <p:nvSpPr>
-          <p:cNvPr id="4" name="Slide Number Placeholder 3"/>
-          <p:cNvSpPr>
-            <a:spLocks noGrp="1"/>
-          </p:cNvSpPr>
-          <p:nvPr>
-            <p:ph type="sldNum" idx="5" sz="quarter"/>
-          </p:nvPr>
-        </p:nvSpPr>
-        <p:spPr/>
-      </p:sp>
-    </p:spTree>
-  </p:cSld>
-  <p:clrMapOvr>
-    <a:masterClrMapping/>
-  </p:clrMapOvr>
-</p:notes>
-</file>
-
-<file path=ppt/notesSlides/notesSlide11.xml><?xml version="1.0" encoding="utf-8"?>
-<p:notes xmlns:a="http://schemas.openxmlformats.org/drawingml/2006/main" xmlns:p="http://schemas.openxmlformats.org/presentationml/2006/main" xmlns:r="http://schemas.openxmlformats.org/officeDocument/2006/relationships">
-  <p:cSld>
-    <p:spTree>
-      <p:nvGrpSpPr>
-        <p:cNvPr id="1" name=""/>
-        <p:cNvGrpSpPr/>
-        <p:nvPr/>
-      </p:nvGrpSpPr>
-      <p:grpSpPr>
-        <a:xfrm>
-          <a:off x="0" y="0"/>
-          <a:ext cx="0" cy="0"/>
-          <a:chOff x="0" y="0"/>
-          <a:chExt cx="0" cy="0"/>
-        </a:xfrm>
-      </p:grpSpPr>
-      <p:sp>
-        <p:nvSpPr>
-          <p:cNvPr id="2" name="Slide Image Placeholder 1"/>
-          <p:cNvSpPr>
-            <a:spLocks noGrp="1"/>
-          </p:cNvSpPr>
-          <p:nvPr>
-            <p:ph type="sldImg" idx="2"/>
-          </p:nvPr>
-        </p:nvSpPr>
-        <p:spPr/>
-      </p:sp>
-      <p:sp>
-        <p:nvSpPr>
-          <p:cNvPr id="3" name="Notes Placeholder 2"/>
-          <p:cNvSpPr>
-            <a:spLocks noGrp="1"/>
-          </p:cNvSpPr>
-          <p:nvPr>
-            <p:ph type="body" idx="3" sz="quarter"/>
-          </p:nvPr>
-        </p:nvSpPr>
-        <p:spPr/>
-        <p:txBody>
-          <a:bodyPr/>
-          <a:lstStyle/>
-          <a:p>
-            <a:r>
-              <a:t>This lands hard with a working cohort. Several will recognize a project of their own. Let them say so.</a:t>
-            </a:r>
-          </a:p>
-        </p:txBody>
-      </p:sp>
-      <p:sp>
-        <p:nvSpPr>
-          <p:cNvPr id="4" name="Slide Number Placeholder 3"/>
-          <p:cNvSpPr>
-            <a:spLocks noGrp="1"/>
-          </p:cNvSpPr>
-          <p:nvPr>
-            <p:ph type="sldNum" idx="5" sz="quarter"/>
-          </p:nvPr>
-        </p:nvSpPr>
-        <p:spPr/>
-      </p:sp>
-    </p:spTree>
-  </p:cSld>
-  <p:clrMapOvr>
-    <a:masterClrMapping/>
-  </p:clrMapOvr>
-</p:notes>
-</file>
-
-<file path=ppt/notesSlides/notesSlide12.xml><?xml version="1.0" encoding="utf-8"?>
-<p:notes xmlns:a="http://schemas.openxmlformats.org/drawingml/2006/main" xmlns:p="http://schemas.openxmlformats.org/presentationml/2006/main" xmlns:r="http://schemas.openxmlformats.org/officeDocument/2006/relationships">
-  <p:cSld>
-    <p:spTree>
-      <p:nvGrpSpPr>
-        <p:cNvPr id="1" name=""/>
-        <p:cNvGrpSpPr/>
-        <p:nvPr/>
-      </p:nvGrpSpPr>
-      <p:grpSpPr>
-        <a:xfrm>
-          <a:off x="0" y="0"/>
-          <a:ext cx="0" cy="0"/>
-          <a:chOff x="0" y="0"/>
-          <a:chExt cx="0" cy="0"/>
-        </a:xfrm>
-      </p:grpSpPr>
-      <p:sp>
-        <p:nvSpPr>
-          <p:cNvPr id="2" name="Slide Image Placeholder 1"/>
-          <p:cNvSpPr>
-            <a:spLocks noGrp="1"/>
-          </p:cNvSpPr>
-          <p:nvPr>
-            <p:ph type="sldImg" idx="2"/>
-          </p:nvPr>
-        </p:nvSpPr>
-        <p:spPr/>
-      </p:sp>
-      <p:sp>
-        <p:nvSpPr>
-          <p:cNvPr id="3" name="Notes Placeholder 2"/>
-          <p:cNvSpPr>
-            <a:spLocks noGrp="1"/>
-          </p:cNvSpPr>
-          <p:nvPr>
-            <p:ph type="body" idx="3" sz="quarter"/>
-          </p:nvPr>
-        </p:nvSpPr>
-        <p:spPr/>
-        <p:txBody>
-          <a:bodyPr/>
-          <a:lstStyle/>
-          <a:p>
-            <a:r>
-              <a:t>Circulate. The most common stall is a topic rather than a decision - listen for a missing verb.</a:t>
-            </a:r>
-          </a:p>
-        </p:txBody>
-      </p:sp>
-      <p:sp>
-        <p:nvSpPr>
-          <p:cNvPr id="4" name="Slide Number Placeholder 3"/>
-          <p:cNvSpPr>
-            <a:spLocks noGrp="1"/>
-          </p:cNvSpPr>
-          <p:nvPr>
-            <p:ph type="sldNum" idx="5" sz="quarter"/>
-          </p:nvPr>
-        </p:nvSpPr>
-        <p:spPr/>
-      </p:sp>
-    </p:spTree>
-  </p:cSld>
-  <p:clrMapOvr>
-    <a:masterClrMapping/>
-  </p:clrMapOvr>
-</p:notes>
-</file>
-
-<file path=ppt/notesSlides/notesSlide13.xml><?xml version="1.0" encoding="utf-8"?>
-<p:notes xmlns:a="http://schemas.openxmlformats.org/drawingml/2006/main" xmlns:p="http://schemas.openxmlformats.org/presentationml/2006/main" xmlns:r="http://schemas.openxmlformats.org/officeDocument/2006/relationships">
-  <p:cSld>
-    <p:spTree>
-      <p:nvGrpSpPr>
-        <p:cNvPr id="1" name=""/>
-        <p:cNvGrpSpPr/>
-        <p:nvPr/>
-      </p:nvGrpSpPr>
-      <p:grpSpPr>
-        <a:xfrm>
-          <a:off x="0" y="0"/>
-          <a:ext cx="0" cy="0"/>
-          <a:chOff x="0" y="0"/>
-          <a:chExt cx="0" cy="0"/>
-        </a:xfrm>
-      </p:grpSpPr>
-      <p:sp>
-        <p:nvSpPr>
-          <p:cNvPr id="2" name="Slide Image Placeholder 1"/>
-          <p:cNvSpPr>
-            <a:spLocks noGrp="1"/>
-          </p:cNvSpPr>
-          <p:nvPr>
-            <p:ph type="sldImg" idx="2"/>
-          </p:nvPr>
-        </p:nvSpPr>
-        <p:spPr/>
-      </p:sp>
-      <p:sp>
-        <p:nvSpPr>
-          <p:cNvPr id="3" name="Notes Placeholder 2"/>
-          <p:cNvSpPr>
-            <a:spLocks noGrp="1"/>
-          </p:cNvSpPr>
-          <p:nvPr>
-            <p:ph type="body" idx="3" sz="quarter"/>
-          </p:nvPr>
-        </p:nvSpPr>
-        <p:spPr/>
-        <p:txBody>
-          <a:bodyPr/>
-          <a:lstStyle/>
-          <a:p>
-            <a:r>
-              <a:t>Good moment for a five-minute stretch before the audit block.</a:t>
-            </a:r>
-          </a:p>
-        </p:txBody>
-      </p:sp>
-      <p:sp>
-        <p:nvSpPr>
-          <p:cNvPr id="4" name="Slide Number Placeholder 3"/>
-          <p:cNvSpPr>
-            <a:spLocks noGrp="1"/>
-          </p:cNvSpPr>
-          <p:nvPr>
-            <p:ph type="sldNum" idx="5" sz="quarter"/>
-          </p:nvPr>
-        </p:nvSpPr>
-        <p:spPr/>
-      </p:sp>
-    </p:spTree>
-  </p:cSld>
-  <p:clrMapOvr>
-    <a:masterClrMapping/>
-  </p:clrMapOvr>
-</p:notes>
-</file>
-
-<file path=ppt/notesSlides/notesSlide14.xml><?xml version="1.0" encoding="utf-8"?>
-<p:notes xmlns:a="http://schemas.openxmlformats.org/drawingml/2006/main" xmlns:p="http://schemas.openxmlformats.org/presentationml/2006/main" xmlns:r="http://schemas.openxmlformats.org/officeDocument/2006/relationships">
-  <p:cSld>
-    <p:spTree>
-      <p:nvGrpSpPr>
-        <p:cNvPr id="1" name=""/>
-        <p:cNvGrpSpPr/>
-        <p:nvPr/>
-      </p:nvGrpSpPr>
-      <p:grpSpPr>
-        <a:xfrm>
-          <a:off x="0" y="0"/>
-          <a:ext cx="0" cy="0"/>
-          <a:chOff x="0" y="0"/>
-          <a:chExt cx="0" cy="0"/>
-        </a:xfrm>
-      </p:grpSpPr>
-      <p:sp>
-        <p:nvSpPr>
-          <p:cNvPr id="2" name="Slide Image Placeholder 1"/>
-          <p:cNvSpPr>
-            <a:spLocks noGrp="1"/>
-          </p:cNvSpPr>
-          <p:nvPr>
-            <p:ph type="sldImg" idx="2"/>
-          </p:nvPr>
-        </p:nvSpPr>
-        <p:spPr/>
-      </p:sp>
-      <p:sp>
-        <p:nvSpPr>
-          <p:cNvPr id="3" name="Notes Placeholder 2"/>
-          <p:cNvSpPr>
-            <a:spLocks noGrp="1"/>
-          </p:cNvSpPr>
-          <p:nvPr>
-            <p:ph type="body" idx="3" sz="quarter"/>
-          </p:nvPr>
-        </p:nvSpPr>
-        <p:spPr/>
-        <p:txBody>
-          <a:bodyPr/>
-          <a:lstStyle/>
-          <a:p>
-            <a:r>
-              <a:t>Rule two is the one that makes them a professional rather than a button-pusher.</a:t>
-            </a:r>
-          </a:p>
-        </p:txBody>
-      </p:sp>
-      <p:sp>
-        <p:nvSpPr>
-          <p:cNvPr id="4" name="Slide Number Placeholder 3"/>
-          <p:cNvSpPr>
-            <a:spLocks noGrp="1"/>
-          </p:cNvSpPr>
-          <p:nvPr>
-            <p:ph type="sldNum" idx="5" sz="quarter"/>
-          </p:nvPr>
-        </p:nvSpPr>
-        <p:spPr/>
-      </p:sp>
-    </p:spTree>
-  </p:cSld>
-  <p:clrMapOvr>
-    <a:masterClrMapping/>
-  </p:clrMapOvr>
-</p:notes>
-</file>
-
-<file path=ppt/notesSlides/notesSlide15.xml><?xml version="1.0" encoding="utf-8"?>
-<p:notes xmlns:a="http://schemas.openxmlformats.org/drawingml/2006/main" xmlns:p="http://schemas.openxmlformats.org/presentationml/2006/main" xmlns:r="http://schemas.openxmlformats.org/officeDocument/2006/relationships">
-  <p:cSld>
-    <p:spTree>
-      <p:nvGrpSpPr>
-        <p:cNvPr id="1" name=""/>
-        <p:cNvGrpSpPr/>
-        <p:nvPr/>
-      </p:nvGrpSpPr>
-      <p:grpSpPr>
-        <a:xfrm>
-          <a:off x="0" y="0"/>
-          <a:ext cx="0" cy="0"/>
-          <a:chOff x="0" y="0"/>
-          <a:chExt cx="0" cy="0"/>
-        </a:xfrm>
-      </p:grpSpPr>
-      <p:sp>
-        <p:nvSpPr>
-          <p:cNvPr id="2" name="Slide Image Placeholder 1"/>
-          <p:cNvSpPr>
-            <a:spLocks noGrp="1"/>
-          </p:cNvSpPr>
-          <p:nvPr>
-            <p:ph type="sldImg" idx="2"/>
-          </p:nvPr>
-        </p:nvSpPr>
-        <p:spPr/>
-      </p:sp>
-      <p:sp>
-        <p:nvSpPr>
-          <p:cNvPr id="3" name="Notes Placeholder 2"/>
-          <p:cNvSpPr>
-            <a:spLocks noGrp="1"/>
-          </p:cNvSpPr>
-          <p:nvPr>
-            <p:ph type="body" idx="3" sz="quarter"/>
-          </p:nvPr>
-        </p:nvSpPr>
-        <p:spPr/>
-        <p:txBody>
-          <a:bodyPr/>
-          <a:lstStyle/>
-          <a:p>
-            <a:r>
-              <a:t>Definition drift: a migration, a new definition, a reorg that moved accounts between segments. Almost every organization has one and almost nobody wrote it down.</a:t>
-            </a:r>
-          </a:p>
-        </p:txBody>
-      </p:sp>
-      <p:sp>
-        <p:nvSpPr>
-          <p:cNvPr id="4" name="Slide Number Placeholder 3"/>
-          <p:cNvSpPr>
-            <a:spLocks noGrp="1"/>
-          </p:cNvSpPr>
-          <p:nvPr>
-            <p:ph type="sldNum" idx="5" sz="quarter"/>
-          </p:nvPr>
-        </p:nvSpPr>
-        <p:spPr/>
-      </p:sp>
-    </p:spTree>
-  </p:cSld>
-  <p:clrMapOvr>
-    <a:masterClrMapping/>
-  </p:clrMapOvr>
-</p:notes>
-</file>
-
-<file path=ppt/notesSlides/notesSlide16.xml><?xml version="1.0" encoding="utf-8"?>
-<p:notes xmlns:a="http://schemas.openxmlformats.org/drawingml/2006/main" xmlns:p="http://schemas.openxmlformats.org/presentationml/2006/main" xmlns:r="http://schemas.openxmlformats.org/officeDocument/2006/relationships">
-  <p:cSld>
-    <p:spTree>
-      <p:nvGrpSpPr>
-        <p:cNvPr id="1" name=""/>
-        <p:cNvGrpSpPr/>
-        <p:nvPr/>
-      </p:nvGrpSpPr>
-      <p:grpSpPr>
-        <a:xfrm>
-          <a:off x="0" y="0"/>
-          <a:ext cx="0" cy="0"/>
-          <a:chOff x="0" y="0"/>
-          <a:chExt cx="0" cy="0"/>
-        </a:xfrm>
-      </p:grpSpPr>
-      <p:sp>
-        <p:nvSpPr>
-          <p:cNvPr id="2" name="Slide Image Placeholder 1"/>
-          <p:cNvSpPr>
-            <a:spLocks noGrp="1"/>
-          </p:cNvSpPr>
-          <p:nvPr>
-            <p:ph type="sldImg" idx="2"/>
-          </p:nvPr>
-        </p:nvSpPr>
-        <p:spPr/>
-      </p:sp>
-      <p:sp>
-        <p:nvSpPr>
-          <p:cNvPr id="3" name="Notes Placeholder 2"/>
-          <p:cNvSpPr>
-            <a:spLocks noGrp="1"/>
-          </p:cNvSpPr>
-          <p:nvPr>
-            <p:ph type="body" idx="3" sz="quarter"/>
-          </p:nvPr>
-        </p:nvSpPr>
-        <p:spPr/>
-        <p:txBody>
-          <a:bodyPr/>
-          <a:lstStyle/>
-          <a:p>
-            <a:r>
-              <a:t>Let them find these rather than telling them first. The moment someone hits the leakage column is the best teaching moment of the night.</a:t>
-            </a:r>
-          </a:p>
-        </p:txBody>
-      </p:sp>
-      <p:sp>
-        <p:nvSpPr>
-          <p:cNvPr id="4" name="Slide Number Placeholder 3"/>
-          <p:cNvSpPr>
-            <a:spLocks noGrp="1"/>
-          </p:cNvSpPr>
-          <p:nvPr>
-            <p:ph type="sldNum" idx="5" sz="quarter"/>
-          </p:nvPr>
-        </p:nvSpPr>
-        <p:spPr/>
-      </p:sp>
-    </p:spTree>
-  </p:cSld>
-  <p:clrMapOvr>
-    <a:masterClrMapping/>
-  </p:clrMapOvr>
-</p:notes>
-</file>
-
-<file path=ppt/notesSlides/notesSlide17.xml><?xml version="1.0" encoding="utf-8"?>
-<p:notes xmlns:a="http://schemas.openxmlformats.org/drawingml/2006/main" xmlns:p="http://schemas.openxmlformats.org/presentationml/2006/main" xmlns:r="http://schemas.openxmlformats.org/officeDocument/2006/relationships">
-  <p:cSld>
-    <p:spTree>
-      <p:nvGrpSpPr>
-        <p:cNvPr id="1" name=""/>
-        <p:cNvGrpSpPr/>
-        <p:nvPr/>
-      </p:nvGrpSpPr>
-      <p:grpSpPr>
-        <a:xfrm>
-          <a:off x="0" y="0"/>
-          <a:ext cx="0" cy="0"/>
-          <a:chOff x="0" y="0"/>
-          <a:chExt cx="0" cy="0"/>
-        </a:xfrm>
-      </p:grpSpPr>
-      <p:sp>
-        <p:nvSpPr>
-          <p:cNvPr id="2" name="Slide Image Placeholder 1"/>
-          <p:cNvSpPr>
-            <a:spLocks noGrp="1"/>
-          </p:cNvSpPr>
-          <p:nvPr>
-            <p:ph type="sldImg" idx="2"/>
-          </p:nvPr>
-        </p:nvSpPr>
-        <p:spPr/>
-      </p:sp>
-      <p:sp>
-        <p:nvSpPr>
-          <p:cNvPr id="3" name="Notes Placeholder 2"/>
-          <p:cNvSpPr>
-            <a:spLocks noGrp="1"/>
-          </p:cNvSpPr>
-          <p:nvPr>
-            <p:ph type="body" idx="3" sz="quarter"/>
-          </p:nvPr>
-        </p:nvSpPr>
-        <p:spPr/>
-        <p:txBody>
-          <a:bodyPr/>
-          <a:lstStyle/>
-          <a:p>
-            <a:r>
-              <a:t>Twelve minutes before the end, stop everyone and ask three people for their CANNOT line. That is the debrief.</a:t>
-            </a:r>
-          </a:p>
-        </p:txBody>
-      </p:sp>
-      <p:sp>
-        <p:nvSpPr>
-          <p:cNvPr id="4" name="Slide Number Placeholder 3"/>
-          <p:cNvSpPr>
-            <a:spLocks noGrp="1"/>
-          </p:cNvSpPr>
-          <p:nvPr>
-            <p:ph type="sldNum" idx="5" sz="quarter"/>
-          </p:nvPr>
-        </p:nvSpPr>
-        <p:spPr/>
-      </p:sp>
-    </p:spTree>
-  </p:cSld>
-  <p:clrMapOvr>
-    <a:masterClrMapping/>
-  </p:clrMapOvr>
-</p:notes>
-</file>
-
-<file path=ppt/notesSlides/notesSlide18.xml><?xml version="1.0" encoding="utf-8"?>
-<p:notes xmlns:a="http://schemas.openxmlformats.org/drawingml/2006/main" xmlns:p="http://schemas.openxmlformats.org/presentationml/2006/main" xmlns:r="http://schemas.openxmlformats.org/officeDocument/2006/relationships">
-  <p:cSld>
-    <p:spTree>
-      <p:nvGrpSpPr>
-        <p:cNvPr id="1" name=""/>
-        <p:cNvGrpSpPr/>
-        <p:nvPr/>
-      </p:nvGrpSpPr>
-      <p:grpSpPr>
-        <a:xfrm>
-          <a:off x="0" y="0"/>
-          <a:ext cx="0" cy="0"/>
-          <a:chOff x="0" y="0"/>
-          <a:chExt cx="0" cy="0"/>
-        </a:xfrm>
-      </p:grpSpPr>
-      <p:sp>
-        <p:nvSpPr>
-          <p:cNvPr id="2" name="Slide Image Placeholder 1"/>
-          <p:cNvSpPr>
-            <a:spLocks noGrp="1"/>
-          </p:cNvSpPr>
-          <p:nvPr>
-            <p:ph type="sldImg" idx="2"/>
-          </p:nvPr>
-        </p:nvSpPr>
-        <p:spPr/>
-      </p:sp>
-      <p:sp>
-        <p:nvSpPr>
-          <p:cNvPr id="3" name="Notes Placeholder 2"/>
-          <p:cNvSpPr>
-            <a:spLocks noGrp="1"/>
-          </p:cNvSpPr>
-          <p:nvPr>
-            <p:ph type="body" idx="3" sz="quarter"/>
-          </p:nvPr>
-        </p:nvSpPr>
-        <p:spPr/>
-        <p:txBody>
-          <a:bodyPr/>
-          <a:lstStyle/>
-          <a:p>
-            <a:r>
-              <a:t>Remind them the student guide has the glossary and troubleshooting list. Send the link again after class.</a:t>
-            </a:r>
-          </a:p>
-        </p:txBody>
-      </p:sp>
-      <p:sp>
-        <p:nvSpPr>
-          <p:cNvPr id="4" name="Slide Number Placeholder 3"/>
-          <p:cNvSpPr>
-            <a:spLocks noGrp="1"/>
-          </p:cNvSpPr>
-          <p:nvPr>
-            <p:ph type="sldNum" idx="5" sz="quarter"/>
-          </p:nvPr>
-        </p:nvSpPr>
-        <p:spPr/>
-      </p:sp>
-    </p:spTree>
-  </p:cSld>
-  <p:clrMapOvr>
-    <a:masterClrMapping/>
-  </p:clrMapOvr>
-</p:notes>
-</file>
-
-<file path=ppt/notesSlides/notesSlide2.xml><?xml version="1.0" encoding="utf-8"?>
-<p:notes xmlns:a="http://schemas.openxmlformats.org/drawingml/2006/main" xmlns:p="http://schemas.openxmlformats.org/presentationml/2006/main" xmlns:r="http://schemas.openxmlformats.org/officeDocument/2006/relationships">
-  <p:cSld>
-    <p:spTree>
-      <p:nvGrpSpPr>
-        <p:cNvPr id="1" name=""/>
-        <p:cNvGrpSpPr/>
-        <p:nvPr/>
-      </p:nvGrpSpPr>
-      <p:grpSpPr>
-        <a:xfrm>
-          <a:off x="0" y="0"/>
-          <a:ext cx="0" cy="0"/>
-          <a:chOff x="0" y="0"/>
-          <a:chExt cx="0" cy="0"/>
-        </a:xfrm>
-      </p:grpSpPr>
-      <p:sp>
-        <p:nvSpPr>
-          <p:cNvPr id="2" name="Slide Image Placeholder 1"/>
-          <p:cNvSpPr>
-            <a:spLocks noGrp="1"/>
-          </p:cNvSpPr>
-          <p:nvPr>
-            <p:ph type="sldImg" idx="2"/>
-          </p:nvPr>
-        </p:nvSpPr>
-        <p:spPr/>
-      </p:sp>
-      <p:sp>
-        <p:nvSpPr>
-          <p:cNvPr id="3" name="Notes Placeholder 2"/>
-          <p:cNvSpPr>
-            <a:spLocks noGrp="1"/>
-          </p:cNvSpPr>
-          <p:nvPr>
-            <p:ph type="body" idx="3" sz="quarter"/>
-          </p:nvPr>
-        </p:nvSpPr>
-        <p:spPr/>
-        <p:txBody>
-          <a:bodyPr/>
-          <a:lstStyle/>
-          <a:p>
-            <a:r>
-              <a:t>Note the shape: two thirds of tonight is spent before anyone analyzes anything. That ratio is the lesson.</a:t>
-            </a:r>
-          </a:p>
-        </p:txBody>
-      </p:sp>
-      <p:sp>
-        <p:nvSpPr>
-          <p:cNvPr id="4" name="Slide Number Placeholder 3"/>
-          <p:cNvSpPr>
-            <a:spLocks noGrp="1"/>
-          </p:cNvSpPr>
-          <p:nvPr>
-            <p:ph type="sldNum" idx="5" sz="quarter"/>
-          </p:nvPr>
-        </p:nvSpPr>
-        <p:spPr/>
-      </p:sp>
-    </p:spTree>
-  </p:cSld>
-  <p:clrMapOvr>
-    <a:masterClrMapping/>
-  </p:clrMapOvr>
-</p:notes>
-</file>
-
-<file path=ppt/notesSlides/notesSlide3.xml><?xml version="1.0" encoding="utf-8"?>
-<p:notes xmlns:a="http://schemas.openxmlformats.org/drawingml/2006/main" xmlns:p="http://schemas.openxmlformats.org/presentationml/2006/main" xmlns:r="http://schemas.openxmlformats.org/officeDocument/2006/relationships">
-  <p:cSld>
-    <p:spTree>
-      <p:nvGrpSpPr>
-        <p:cNvPr id="1" name=""/>
-        <p:cNvGrpSpPr/>
-        <p:nvPr/>
-      </p:nvGrpSpPr>
-      <p:grpSpPr>
-        <a:xfrm>
-          <a:off x="0" y="0"/>
-          <a:ext cx="0" cy="0"/>
-          <a:chOff x="0" y="0"/>
-          <a:chExt cx="0" cy="0"/>
-        </a:xfrm>
-      </p:grpSpPr>
-      <p:sp>
-        <p:nvSpPr>
-          <p:cNvPr id="2" name="Slide Image Placeholder 1"/>
-          <p:cNvSpPr>
-            <a:spLocks noGrp="1"/>
-          </p:cNvSpPr>
-          <p:nvPr>
-            <p:ph type="sldImg" idx="2"/>
-          </p:nvPr>
-        </p:nvSpPr>
-        <p:spPr/>
-      </p:sp>
-      <p:sp>
-        <p:nvSpPr>
-          <p:cNvPr id="3" name="Notes Placeholder 2"/>
-          <p:cNvSpPr>
-            <a:spLocks noGrp="1"/>
-          </p:cNvSpPr>
-          <p:nvPr>
-            <p:ph type="body" idx="3" sz="quarter"/>
-          </p:nvPr>
-        </p:nvSpPr>
-        <p:spPr/>
-        <p:txBody>
-          <a:bodyPr/>
-          <a:lstStyle/>
-          <a:p>
-            <a:r>
-              <a:t>Say the last line out loud. Half the room is quietly worried about the data question and has not asked it.</a:t>
-            </a:r>
-          </a:p>
-        </p:txBody>
-      </p:sp>
-      <p:sp>
-        <p:nvSpPr>
-          <p:cNvPr id="4" name="Slide Number Placeholder 3"/>
-          <p:cNvSpPr>
-            <a:spLocks noGrp="1"/>
-          </p:cNvSpPr>
-          <p:nvPr>
-            <p:ph type="sldNum" idx="5" sz="quarter"/>
-          </p:nvPr>
-        </p:nvSpPr>
-        <p:spPr/>
-      </p:sp>
-    </p:spTree>
-  </p:cSld>
-  <p:clrMapOvr>
-    <a:masterClrMapping/>
-  </p:clrMapOvr>
-</p:notes>
-</file>
-
-<file path=ppt/notesSlides/notesSlide4.xml><?xml version="1.0" encoding="utf-8"?>
-<p:notes xmlns:a="http://schemas.openxmlformats.org/drawingml/2006/main" xmlns:p="http://schemas.openxmlformats.org/presentationml/2006/main" xmlns:r="http://schemas.openxmlformats.org/officeDocument/2006/relationships">
-  <p:cSld>
-    <p:spTree>
-      <p:nvGrpSpPr>
-        <p:cNvPr id="1" name=""/>
-        <p:cNvGrpSpPr/>
-        <p:nvPr/>
-      </p:nvGrpSpPr>
-      <p:grpSpPr>
-        <a:xfrm>
-          <a:off x="0" y="0"/>
-          <a:ext cx="0" cy="0"/>
-          <a:chOff x="0" y="0"/>
-          <a:chExt cx="0" cy="0"/>
-        </a:xfrm>
-      </p:grpSpPr>
-      <p:sp>
-        <p:nvSpPr>
-          <p:cNvPr id="2" name="Slide Image Placeholder 1"/>
-          <p:cNvSpPr>
-            <a:spLocks noGrp="1"/>
-          </p:cNvSpPr>
-          <p:nvPr>
-            <p:ph type="sldImg" idx="2"/>
-          </p:nvPr>
-        </p:nvSpPr>
-        <p:spPr/>
-      </p:sp>
-      <p:sp>
-        <p:nvSpPr>
-          <p:cNvPr id="3" name="Notes Placeholder 2"/>
-          <p:cNvSpPr>
-            <a:spLocks noGrp="1"/>
-          </p:cNvSpPr>
-          <p:nvPr>
-            <p:ph type="body" idx="3" sz="quarter"/>
-          </p:nvPr>
-        </p:nvSpPr>
-        <p:spPr/>
-        <p:txBody>
-          <a:bodyPr/>
-          <a:lstStyle/>
-          <a:p>
-            <a:r>
-              <a:t>This slide is the reframe. They are not learning new statistics tonight - they are learning to aim it. Confidence intervals from Module 03 show up in every single use case, which is why that row is highlighted.</a:t>
-            </a:r>
-          </a:p>
-        </p:txBody>
-      </p:sp>
-      <p:sp>
-        <p:nvSpPr>
-          <p:cNvPr id="4" name="Slide Number Placeholder 3"/>
-          <p:cNvSpPr>
-            <a:spLocks noGrp="1"/>
-          </p:cNvSpPr>
-          <p:nvPr>
-            <p:ph type="sldNum" idx="5" sz="quarter"/>
-          </p:nvPr>
-        </p:nvSpPr>
-        <p:spPr/>
-      </p:sp>
-    </p:spTree>
-  </p:cSld>
-  <p:clrMapOvr>
-    <a:masterClrMapping/>
-  </p:clrMapOvr>
-</p:notes>
-</file>
-
-<file path=ppt/notesSlides/notesSlide5.xml><?xml version="1.0" encoding="utf-8"?>
-<p:notes xmlns:a="http://schemas.openxmlformats.org/drawingml/2006/main" xmlns:p="http://schemas.openxmlformats.org/presentationml/2006/main" xmlns:r="http://schemas.openxmlformats.org/officeDocument/2006/relationships">
-  <p:cSld>
-    <p:spTree>
-      <p:nvGrpSpPr>
-        <p:cNvPr id="1" name=""/>
-        <p:cNvGrpSpPr/>
-        <p:nvPr/>
-      </p:nvGrpSpPr>
-      <p:grpSpPr>
-        <a:xfrm>
-          <a:off x="0" y="0"/>
-          <a:ext cx="0" cy="0"/>
-          <a:chOff x="0" y="0"/>
-          <a:chExt cx="0" cy="0"/>
-        </a:xfrm>
-      </p:grpSpPr>
-      <p:sp>
-        <p:nvSpPr>
-          <p:cNvPr id="2" name="Slide Image Placeholder 1"/>
-          <p:cNvSpPr>
-            <a:spLocks noGrp="1"/>
-          </p:cNvSpPr>
-          <p:nvPr>
-            <p:ph type="sldImg" idx="2"/>
-          </p:nvPr>
-        </p:nvSpPr>
-        <p:spPr/>
-      </p:sp>
-      <p:sp>
-        <p:nvSpPr>
-          <p:cNvPr id="3" name="Notes Placeholder 2"/>
-          <p:cNvSpPr>
-            <a:spLocks noGrp="1"/>
-          </p:cNvSpPr>
-          <p:nvPr>
-            <p:ph type="body" idx="3" sz="quarter"/>
-          </p:nvPr>
-        </p:nvSpPr>
-        <p:spPr/>
-        <p:txBody>
-          <a:bodyPr/>
-          <a:lstStyle/>
-          <a:p>
-            <a:r>
-              <a:t>Do not rush this slide. For a working cohort this is the single most important ground rule, and saying it plainly buys their trust for the rest of the evening.</a:t>
-            </a:r>
-          </a:p>
-        </p:txBody>
-      </p:sp>
-      <p:sp>
-        <p:nvSpPr>
-          <p:cNvPr id="4" name="Slide Number Placeholder 3"/>
-          <p:cNvSpPr>
-            <a:spLocks noGrp="1"/>
-          </p:cNvSpPr>
-          <p:nvPr>
-            <p:ph type="sldNum" idx="5" sz="quarter"/>
-          </p:nvPr>
-        </p:nvSpPr>
-        <p:spPr/>
-      </p:sp>
-    </p:spTree>
-  </p:cSld>
-  <p:clrMapOvr>
-    <a:masterClrMapping/>
-  </p:clrMapOvr>
-</p:notes>
-</file>
-
-<file path=ppt/notesSlides/notesSlide6.xml><?xml version="1.0" encoding="utf-8"?>
-<p:notes xmlns:a="http://schemas.openxmlformats.org/drawingml/2006/main" xmlns:p="http://schemas.openxmlformats.org/presentationml/2006/main" xmlns:r="http://schemas.openxmlformats.org/officeDocument/2006/relationships">
-  <p:cSld>
-    <p:spTree>
-      <p:nvGrpSpPr>
-        <p:cNvPr id="1" name=""/>
-        <p:cNvGrpSpPr/>
-        <p:nvPr/>
-      </p:nvGrpSpPr>
-      <p:grpSpPr>
-        <a:xfrm>
-          <a:off x="0" y="0"/>
-          <a:ext cx="0" cy="0"/>
-          <a:chOff x="0" y="0"/>
-          <a:chExt cx="0" cy="0"/>
-        </a:xfrm>
-      </p:grpSpPr>
-      <p:sp>
-        <p:nvSpPr>
-          <p:cNvPr id="2" name="Slide Image Placeholder 1"/>
-          <p:cNvSpPr>
-            <a:spLocks noGrp="1"/>
-          </p:cNvSpPr>
-          <p:nvPr>
-            <p:ph type="sldImg" idx="2"/>
-          </p:nvPr>
-        </p:nvSpPr>
-        <p:spPr/>
-      </p:sp>
-      <p:sp>
-        <p:nvSpPr>
-          <p:cNvPr id="3" name="Notes Placeholder 2"/>
-          <p:cNvSpPr>
-            <a:spLocks noGrp="1"/>
-          </p:cNvSpPr>
-          <p:nvPr>
-            <p:ph type="body" idx="3" sz="quarter"/>
-          </p:nvPr>
-        </p:nvSpPr>
-        <p:spPr/>
-        <p:txBody>
-          <a:bodyPr/>
-          <a:lstStyle/>
-          <a:p>
-            <a:r>
-              <a:t>Ask for a show of hands per tool. Pair up anyone on a free chat tool so they can share the copy-paste load.</a:t>
-            </a:r>
-          </a:p>
-        </p:txBody>
-      </p:sp>
-      <p:sp>
-        <p:nvSpPr>
-          <p:cNvPr id="4" name="Slide Number Placeholder 3"/>
-          <p:cNvSpPr>
-            <a:spLocks noGrp="1"/>
-          </p:cNvSpPr>
-          <p:nvPr>
-            <p:ph type="sldNum" idx="5" sz="quarter"/>
-          </p:nvPr>
-        </p:nvSpPr>
-        <p:spPr/>
-      </p:sp>
-    </p:spTree>
-  </p:cSld>
-  <p:clrMapOvr>
-    <a:masterClrMapping/>
-  </p:clrMapOvr>
-</p:notes>
-</file>
-
-<file path=ppt/notesSlides/notesSlide7.xml><?xml version="1.0" encoding="utf-8"?>
-<p:notes xmlns:a="http://schemas.openxmlformats.org/drawingml/2006/main" xmlns:p="http://schemas.openxmlformats.org/presentationml/2006/main" xmlns:r="http://schemas.openxmlformats.org/officeDocument/2006/relationships">
-  <p:cSld>
-    <p:spTree>
-      <p:nvGrpSpPr>
-        <p:cNvPr id="1" name=""/>
-        <p:cNvGrpSpPr/>
-        <p:nvPr/>
-      </p:nvGrpSpPr>
-      <p:grpSpPr>
-        <a:xfrm>
-          <a:off x="0" y="0"/>
-          <a:ext cx="0" cy="0"/>
-          <a:chOff x="0" y="0"/>
-          <a:chExt cx="0" cy="0"/>
-        </a:xfrm>
-      </p:grpSpPr>
-      <p:sp>
-        <p:nvSpPr>
-          <p:cNvPr id="2" name="Slide Image Placeholder 1"/>
-          <p:cNvSpPr>
-            <a:spLocks noGrp="1"/>
-          </p:cNvSpPr>
-          <p:nvPr>
-            <p:ph type="sldImg" idx="2"/>
-          </p:nvPr>
-        </p:nvSpPr>
-        <p:spPr/>
-      </p:sp>
-      <p:sp>
-        <p:nvSpPr>
-          <p:cNvPr id="3" name="Notes Placeholder 2"/>
-          <p:cNvSpPr>
-            <a:spLocks noGrp="1"/>
-          </p:cNvSpPr>
-          <p:nvPr>
-            <p:ph type="body" idx="3" sz="quarter"/>
-          </p:nvPr>
-        </p:nvSpPr>
-        <p:spPr/>
-        <p:txBody>
-          <a:bodyPr/>
-          <a:lstStyle/>
-          <a:p>
-            <a:r>
-              <a:t>Do this live on screen. It takes about 30 seconds and it is the first moment the room sees an agent do real work. Walk the aisles afterwards - the OneDrive mistake is the one people make.</a:t>
-            </a:r>
-          </a:p>
-        </p:txBody>
-      </p:sp>
-      <p:sp>
-        <p:nvSpPr>
-          <p:cNvPr id="4" name="Slide Number Placeholder 3"/>
-          <p:cNvSpPr>
-            <a:spLocks noGrp="1"/>
-          </p:cNvSpPr>
-          <p:nvPr>
-            <p:ph type="sldNum" idx="5" sz="quarter"/>
-          </p:nvPr>
-        </p:nvSpPr>
-        <p:spPr/>
-      </p:sp>
-    </p:spTree>
-  </p:cSld>
-  <p:clrMapOvr>
-    <a:masterClrMapping/>
-  </p:clrMapOvr>
-</p:notes>
-</file>
-
-<file path=ppt/notesSlides/notesSlide8.xml><?xml version="1.0" encoding="utf-8"?>
-<p:notes xmlns:a="http://schemas.openxmlformats.org/drawingml/2006/main" xmlns:p="http://schemas.openxmlformats.org/presentationml/2006/main" xmlns:r="http://schemas.openxmlformats.org/officeDocument/2006/relationships">
-  <p:cSld>
-    <p:spTree>
-      <p:nvGrpSpPr>
-        <p:cNvPr id="1" name=""/>
-        <p:cNvGrpSpPr/>
-        <p:nvPr/>
-      </p:nvGrpSpPr>
-      <p:grpSpPr>
-        <a:xfrm>
-          <a:off x="0" y="0"/>
-          <a:ext cx="0" cy="0"/>
-          <a:chOff x="0" y="0"/>
-          <a:chExt cx="0" cy="0"/>
-        </a:xfrm>
-      </p:grpSpPr>
-      <p:sp>
-        <p:nvSpPr>
-          <p:cNvPr id="2" name="Slide Image Placeholder 1"/>
-          <p:cNvSpPr>
-            <a:spLocks noGrp="1"/>
-          </p:cNvSpPr>
-          <p:nvPr>
-            <p:ph type="sldImg" idx="2"/>
-          </p:nvPr>
-        </p:nvSpPr>
-        <p:spPr/>
-      </p:sp>
-      <p:sp>
-        <p:nvSpPr>
-          <p:cNvPr id="3" name="Notes Placeholder 2"/>
-          <p:cNvSpPr>
-            <a:spLocks noGrp="1"/>
-          </p:cNvSpPr>
-          <p:nvPr>
-            <p:ph type="body" idx="3" sz="quarter"/>
-          </p:nvPr>
-        </p:nvSpPr>
-        <p:spPr/>
-        <p:txBody>
-          <a:bodyPr/>
-          <a:lstStyle/>
-          <a:p>
-            <a:r>
-              <a:t>Let this one sit for a beat before you talk over it.</a:t>
-            </a:r>
-          </a:p>
-        </p:txBody>
-      </p:sp>
-      <p:sp>
-        <p:nvSpPr>
-          <p:cNvPr id="4" name="Slide Number Placeholder 3"/>
-          <p:cNvSpPr>
-            <a:spLocks noGrp="1"/>
-          </p:cNvSpPr>
-          <p:nvPr>
-            <p:ph type="sldNum" idx="5" sz="quarter"/>
-          </p:nvPr>
-        </p:nvSpPr>
-        <p:spPr/>
-      </p:sp>
-    </p:spTree>
-  </p:cSld>
-  <p:clrMapOvr>
-    <a:masterClrMapping/>
-  </p:clrMapOvr>
-</p:notes>
-</file>
-
-<file path=ppt/notesSlides/notesSlide9.xml><?xml version="1.0" encoding="utf-8"?>
-<p:notes xmlns:a="http://schemas.openxmlformats.org/drawingml/2006/main" xmlns:p="http://schemas.openxmlformats.org/presentationml/2006/main" xmlns:r="http://schemas.openxmlformats.org/officeDocument/2006/relationships">
-  <p:cSld>
-    <p:spTree>
-      <p:nvGrpSpPr>
-        <p:cNvPr id="1" name=""/>
-        <p:cNvGrpSpPr/>
-        <p:nvPr/>
-      </p:nvGrpSpPr>
-      <p:grpSpPr>
-        <a:xfrm>
-          <a:off x="0" y="0"/>
-          <a:ext cx="0" cy="0"/>
-          <a:chOff x="0" y="0"/>
-          <a:chExt cx="0" cy="0"/>
-        </a:xfrm>
-      </p:grpSpPr>
-      <p:sp>
-        <p:nvSpPr>
-          <p:cNvPr id="2" name="Slide Image Placeholder 1"/>
-          <p:cNvSpPr>
-            <a:spLocks noGrp="1"/>
-          </p:cNvSpPr>
-          <p:nvPr>
-            <p:ph type="sldImg" idx="2"/>
-          </p:nvPr>
-        </p:nvSpPr>
-        <p:spPr/>
-      </p:sp>
-      <p:sp>
-        <p:nvSpPr>
-          <p:cNvPr id="3" name="Notes Placeholder 2"/>
-          <p:cNvSpPr>
-            <a:spLocks noGrp="1"/>
-          </p:cNvSpPr>
-          <p:nvPr>
-            <p:ph type="body" idx="3" sz="quarter"/>
-          </p:nvPr>
-        </p:nvSpPr>
-        <p:spPr/>
-        <p:txBody>
-          <a:bodyPr/>
-          <a:lstStyle/>
-          <a:p>
-            <a:r>
-              <a:t>Ask the room: who has been handed an analysis nobody used? Hands go up. That is the hook.</a:t>
-            </a:r>
-          </a:p>
-        </p:txBody>
-      </p:sp>
-      <p:sp>
-        <p:nvSpPr>
-          <p:cNvPr id="4" name="Slide Number Placeholder 3"/>
-          <p:cNvSpPr>
-            <a:spLocks noGrp="1"/>
-          </p:cNvSpPr>
-          <p:nvPr>
-            <p:ph type="sldNum" idx="5" sz="quarter"/>
-          </p:nvPr>
-        </p:nvSpPr>
-        <p:spPr/>
-      </p:sp>
-    </p:spTree>
-  </p:cSld>
-  <p:clrMapOvr>
-    <a:masterClrMapping/>
-  </p:clrMapOvr>
-</p:notes>
 </file>
 
 <file path=ppt/slideLayouts/slideLayout1.xml><?xml version="1.0" encoding="utf-8"?>

</xml_diff>